<commit_message>
fix(demo): clean 195 baseline seed, fix modal map and phone label, update slide 14 copy
</commit_message>
<xml_diff>
--- a/mustercommand_coned_floor07_briefing.pptx
+++ b/mustercommand_coned_floor07_briefing.pptx
@@ -6063,7 +6063,7 @@
                   <a:schemeClr val="tx1"/>
                 </a:solidFill>
               </a:rPr>
-              <a:t>Pilot readiness: features verified and active in today's demo</a:t>
+              <a:t>Pilot readiness: built and tested for the pilot version</a:t>
             </a:r>
             <a:endParaRPr lang="en-US" sz="3200" dirty="0"/>
           </a:p>
@@ -6719,7 +6719,7 @@
                   <a:srgbClr val="64748B"/>
                 </a:solidFill>
               </a:rPr>
-              <a:t>Integrated and live in today's demo build (survives restarts, private numbers, phone connect).</a:t>
+              <a:t>Built and tested for the pilot version (survives restarts, private numbers, phone connect).</a:t>
             </a:r>
             <a:endParaRPr lang="en-US" sz="1400" dirty="0"/>
           </a:p>

</xml_diff>